<commit_message>
Add beam-calc practice repo source and clarify Lesson 1 setup
practice/beam-calc/ holds the files Lesson 1 Exercise 2 expects in the
beam-calc template repository (beam.m, tests/testBeam.m, README.md,
AGENTS.md, .gitignore), matching what Lessons 1-2 show on screen.
practice/README.md tells the course lead how to publish it as a public
template and share the link.

Lesson 1: the practice repo now comes from the 'course lead' (slides 3
and 10, with notes on how templates work). The 'Your Own Code' slide is
retitled 'After Class: Your Own Repo' and moved next to the Agent-Ready
Checklist, so it no longer sits between Exercises 2 and 3.

Co-Authored-By: Claude Opus 5.5 <noreply@anthropic.com>
Claude-Session: https://claude.ai/code/session_01EceYBcFXTaBjFSFEfqpJfg
</commit_message>
<xml_diff>
--- a/Lesson Material/LSN 1 -  Introduction to GIT and GitHub/Agentic_AI_for_Engineering.pptx
+++ b/Lesson Material/LSN 1 -  Introduction to GIT and GitHub/Agentic_AI_for_Engineering.pptx
@@ -18,7 +18,6 @@
     <p:sldId id="263" r:id="rIdS8"/>
     <p:sldId id="264" r:id="rIdS9"/>
     <p:sldId id="265" r:id="rIdS10"/>
-    <p:sldId id="266" r:id="rIdS11"/>
     <p:sldId id="267" r:id="rIdS12"/>
     <p:sldId id="268" r:id="rIdS13"/>
     <p:sldId id="269" r:id="rIdS14"/>
@@ -27,6 +26,7 @@
     <p:sldId id="272" r:id="rIdS17"/>
     <p:sldId id="273" r:id="rIdS18"/>
     <p:sldId id="274" r:id="rIdS19"/>
+    <p:sldId id="266" r:id="rIdS11"/>
     <p:sldId id="275" r:id="rIdS20"/>
     <p:sldId id="276" r:id="rIdS21"/>
     <p:sldId id="277" r:id="rIdS22"/>
@@ -582,8 +582,7 @@
           <a:lstStyle/>
           <a:p>
             <a:r>
-              <a:rPr lang="en-US" dirty="0"/>
-              <a:t>Using the template gives each participant their own copy with full write access, which a plain clone of the instructor repo would not. Recommend keeping repos out of OneDrive-synced folders; OneDrive and Git can fight over the same files.</a:t>
+              <a:t>The course lead shares a link to a GitHub template repository (beam-calc). Use this template makes each participant a separate copy that they own, with full write access; a plain clone of the course lead’s repo would not let them push. They then clone their own copy, not the template. Recommend keeping repos out of OneDrive-synced folders; OneDrive and Git can fight over the same files.</a:t>
             </a:r>
           </a:p>
         </p:txBody>
@@ -641,8 +640,7 @@
           <a:lstStyle/>
           <a:p>
             <a:r>
-              <a:rPr lang="en-US" dirty="0"/>
-              <a:t>Reference slide; participants don't do this in class. This is how they'll put their own existing course code on GitHub before Lesson 2. Emphasize the private checkbox on Publish.</a:t>
+              <a:t>Homework, not an in-class exercise. Participants do this after class with one of their own projects (scripts, models, course code) before Lesson 2. It sits just before the Agent-Ready Checklist so they see the steps that get them to its first item. Emphasize the private checkbox on Publish.</a:t>
             </a:r>
           </a:p>
         </p:txBody>
@@ -1230,8 +1228,7 @@
           <a:lstStyle/>
           <a:p>
             <a:r>
-              <a:rPr lang="en-US" dirty="0"/>
-              <a:t>Homework before Lesson 2: pick one of your own projects and bring it to this state. Lesson 2 starts from a repo that meets this checklist.</a:t>
+              <a:t>Homework before Lesson 2: pick one of your own projects and bring it to this state. The previous slide has the steps for getting it onto GitHub. Lesson 2 starts from a repo that meets this checklist.</a:t>
             </a:r>
           </a:p>
         </p:txBody>
@@ -1466,8 +1463,7 @@
           <a:lstStyle/>
           <a:p>
             <a:r>
-              <a:rPr lang="en-US" dirty="0"/>
-              <a:t>Ideally participants complete this before class. Government or managed laptops may block installs, so coordinate with IT ahead of time. Use whatever account type your organization directs; the lesson works the same either way.</a:t>
+              <a:t>Ideally participants complete this before class. Government or managed laptops may block installs, so coordinate with IT ahead of time. Use whatever account type your organization directs; the lesson works the same either way. Course lead: before class, publish the beam-calc template repository (see practice/README.md in the course repo) and send its link with these prerequisites.</a:t>
             </a:r>
           </a:p>
         </p:txBody>
@@ -3907,6 +3903,10 @@
           </a:solidFill>
           <a:ln/>
         </p:spPr>
+        <p:txBody>
+          <a:bodyPr/>
+          <a:p/>
+        </p:txBody>
       </p:sp>
       <p:sp xmlns:p="http://schemas.openxmlformats.org/presentationml/2006/main" xmlns:a="http://schemas.openxmlformats.org/drawingml/2006/main" xmlns:r="http://schemas.openxmlformats.org/officeDocument/2006/relationships">
         <p:nvSpPr>
@@ -4072,7 +4072,7 @@
                 <a:ea typeface="+mn-ea"/>
                 <a:cs typeface="+mn-cs"/>
               </a:rPr>
-              <a:t>Open the beam-calc link from your instructor.</a:t>
+              <a:t>Open the course lead’s beam-calc link.</a:t>
             </a:r>
             <a:endParaRPr lang="en-US" sz="2025" dirty="0"/>
           </a:p>
@@ -4685,7 +4685,7 @@
           <a:p>
             <a:r>
               <a:rPr lang="en-US" dirty="0"/>
-              <a:t>Your Own Code: Create &amp; Publish</a:t>
+              <a:t>After Class: Your Own Repo</a:t>
             </a:r>
             <a:endParaRPr lang="en-US" dirty="0"/>
           </a:p>
@@ -4712,6 +4712,10 @@
           </a:solidFill>
           <a:ln/>
         </p:spPr>
+        <p:txBody>
+          <a:bodyPr/>
+          <a:p/>
+        </p:txBody>
       </p:sp>
       <p:sp xmlns:p="http://schemas.openxmlformats.org/presentationml/2006/main" xmlns:a="http://schemas.openxmlformats.org/drawingml/2006/main" xmlns:r="http://schemas.openxmlformats.org/officeDocument/2006/relationships">
         <p:nvSpPr>
@@ -4748,7 +4752,7 @@
                 <a:ea typeface="+mn-ea"/>
                 <a:cs typeface="+mn-cs"/>
               </a:rPr>
-              <a:t>REFERENCE · DO BEFORE LESSON 2</a:t>
+              <a:t>AFTER CLASS · BEFORE LESSON 2</a:t>
             </a:r>
             <a:endParaRPr lang="en-US" sz="1800" dirty="0"/>
           </a:p>
@@ -4792,7 +4796,7 @@
                 <a:ea typeface="+mn-ea"/>
                 <a:cs typeface="+mn-cs"/>
               </a:rPr>
-              <a:t>To put an existing project folder (scripts, models, course code) under version control:</a:t>
+              <a:t>Not a beam-calc exercise. After class, put one of your own projects on GitHub:</a:t>
             </a:r>
             <a:endParaRPr lang="en-US" sz="2100" dirty="0"/>
           </a:p>
@@ -5400,6 +5404,10 @@
           </a:solidFill>
           <a:ln/>
         </p:spPr>
+        <p:txBody>
+          <a:bodyPr/>
+          <a:p/>
+        </p:txBody>
       </p:sp>
       <p:sp xmlns:p="http://schemas.openxmlformats.org/presentationml/2006/main" xmlns:a="http://schemas.openxmlformats.org/drawingml/2006/main" xmlns:r="http://schemas.openxmlformats.org/officeDocument/2006/relationships">
         <p:nvSpPr>
@@ -5475,7 +5483,7 @@
         </p:nvSpPr>
         <p:spPr>
           <a:xfrm>
-            <a:off x="133350" y="3524250"/>
+            <a:off x="133350" y="5810250"/>
             <a:ext cx="1442184" cy="381000"/>
           </a:xfrm>
           <a:prstGeom prst="rect">
@@ -5502,7 +5510,7 @@
                   <a:schemeClr val="accent2"/>
                 </a:solidFill>
               </a:rPr>
-              <a:t>Clone</a:t>
+              <a:t>Agent-Ready</a:t>
             </a:r>
             <a:endParaRPr lang="en-US" sz="1800" b="1" dirty="0"/>
           </a:p>
@@ -15259,6 +15267,10 @@
           </a:solidFill>
           <a:ln/>
         </p:spPr>
+        <p:txBody>
+          <a:bodyPr/>
+          <a:p/>
+        </p:txBody>
       </p:sp>
       <p:sp xmlns:p="http://schemas.openxmlformats.org/presentationml/2006/main" xmlns:a="http://schemas.openxmlformats.org/drawingml/2006/main" xmlns:r="http://schemas.openxmlformats.org/officeDocument/2006/relationships">
         <p:nvSpPr>
@@ -15279,6 +15291,10 @@
           </a:solidFill>
           <a:ln/>
         </p:spPr>
+        <p:txBody>
+          <a:bodyPr/>
+          <a:p/>
+        </p:txBody>
       </p:sp>
       <p:sp xmlns:p="http://schemas.openxmlformats.org/presentationml/2006/main" xmlns:a="http://schemas.openxmlformats.org/drawingml/2006/main" xmlns:r="http://schemas.openxmlformats.org/officeDocument/2006/relationships">
         <p:nvSpPr>
@@ -15301,6 +15317,10 @@
             <a:prstDash val="solid"/>
           </a:ln>
         </p:spPr>
+        <p:txBody>
+          <a:bodyPr/>
+          <a:p/>
+        </p:txBody>
       </p:sp>
       <p:sp xmlns:p="http://schemas.openxmlformats.org/presentationml/2006/main" xmlns:a="http://schemas.openxmlformats.org/drawingml/2006/main" xmlns:r="http://schemas.openxmlformats.org/officeDocument/2006/relationships">
         <p:nvSpPr>
@@ -15311,7 +15331,7 @@
         <p:spPr>
           <a:xfrm>
             <a:off x="2355850" y="2403475"/>
-            <a:ext cx="3831928" cy="381000"/>
+            <a:ext cx="9000000" cy="381000"/>
           </a:xfrm>
           <a:prstGeom prst="rect">
             <a:avLst/>
@@ -15349,6 +15369,17 @@
                 <a:cs typeface="+mn-cs"/>
               </a:rPr>
               <a:t>private</a:t>
+            </a:r>
+            <a:r>
+              <a:rPr lang="en-US" sz="2025" dirty="0">
+                <a:solidFill>
+                  <a:srgbClr val="000000"/>
+                </a:solidFill>
+                <a:latin typeface="+mn-lt"/>
+                <a:ea typeface="+mn-ea"/>
+                <a:cs typeface="+mn-cs"/>
+              </a:rPr>
+              <a:t> (steps on the previous slide)</a:t>
             </a:r>
             <a:endParaRPr lang="en-US" sz="2025" dirty="0"/>
           </a:p>
@@ -15373,6 +15404,10 @@
           </a:solidFill>
           <a:ln/>
         </p:spPr>
+        <p:txBody>
+          <a:bodyPr/>
+          <a:p/>
+        </p:txBody>
       </p:sp>
       <p:sp xmlns:p="http://schemas.openxmlformats.org/presentationml/2006/main" xmlns:a="http://schemas.openxmlformats.org/drawingml/2006/main" xmlns:r="http://schemas.openxmlformats.org/officeDocument/2006/relationships">
         <p:nvSpPr>
@@ -15395,6 +15430,10 @@
             <a:prstDash val="solid"/>
           </a:ln>
         </p:spPr>
+        <p:txBody>
+          <a:bodyPr/>
+          <a:p/>
+        </p:txBody>
       </p:sp>
       <p:sp xmlns:p="http://schemas.openxmlformats.org/presentationml/2006/main" xmlns:a="http://schemas.openxmlformats.org/drawingml/2006/main" xmlns:r="http://schemas.openxmlformats.org/officeDocument/2006/relationships">
         <p:nvSpPr>
@@ -15456,6 +15495,10 @@
           </a:solidFill>
           <a:ln/>
         </p:spPr>
+        <p:txBody>
+          <a:bodyPr/>
+          <a:p/>
+        </p:txBody>
       </p:sp>
       <p:sp xmlns:p="http://schemas.openxmlformats.org/presentationml/2006/main" xmlns:a="http://schemas.openxmlformats.org/drawingml/2006/main" xmlns:r="http://schemas.openxmlformats.org/officeDocument/2006/relationships">
         <p:nvSpPr>
@@ -15478,6 +15521,10 @@
             <a:prstDash val="solid"/>
           </a:ln>
         </p:spPr>
+        <p:txBody>
+          <a:bodyPr/>
+          <a:p/>
+        </p:txBody>
       </p:sp>
       <p:sp xmlns:p="http://schemas.openxmlformats.org/presentationml/2006/main" xmlns:a="http://schemas.openxmlformats.org/drawingml/2006/main" xmlns:r="http://schemas.openxmlformats.org/officeDocument/2006/relationships">
         <p:nvSpPr>
@@ -15539,6 +15586,10 @@
           </a:solidFill>
           <a:ln/>
         </p:spPr>
+        <p:txBody>
+          <a:bodyPr/>
+          <a:p/>
+        </p:txBody>
       </p:sp>
       <p:sp xmlns:p="http://schemas.openxmlformats.org/presentationml/2006/main" xmlns:a="http://schemas.openxmlformats.org/drawingml/2006/main" xmlns:r="http://schemas.openxmlformats.org/officeDocument/2006/relationships">
         <p:nvSpPr>
@@ -15561,6 +15612,10 @@
             <a:prstDash val="solid"/>
           </a:ln>
         </p:spPr>
+        <p:txBody>
+          <a:bodyPr/>
+          <a:p/>
+        </p:txBody>
       </p:sp>
       <p:sp xmlns:p="http://schemas.openxmlformats.org/presentationml/2006/main" xmlns:a="http://schemas.openxmlformats.org/drawingml/2006/main" xmlns:r="http://schemas.openxmlformats.org/officeDocument/2006/relationships">
         <p:nvSpPr>
@@ -15622,6 +15677,10 @@
           </a:solidFill>
           <a:ln/>
         </p:spPr>
+        <p:txBody>
+          <a:bodyPr/>
+          <a:p/>
+        </p:txBody>
       </p:sp>
       <p:sp xmlns:p="http://schemas.openxmlformats.org/presentationml/2006/main" xmlns:a="http://schemas.openxmlformats.org/drawingml/2006/main" xmlns:r="http://schemas.openxmlformats.org/officeDocument/2006/relationships">
         <p:nvSpPr>
@@ -15644,6 +15703,10 @@
             <a:prstDash val="solid"/>
           </a:ln>
         </p:spPr>
+        <p:txBody>
+          <a:bodyPr/>
+          <a:p/>
+        </p:txBody>
       </p:sp>
       <p:sp xmlns:p="http://schemas.openxmlformats.org/presentationml/2006/main" xmlns:a="http://schemas.openxmlformats.org/drawingml/2006/main" xmlns:r="http://schemas.openxmlformats.org/officeDocument/2006/relationships">
         <p:nvSpPr>
@@ -15705,6 +15768,10 @@
           </a:solidFill>
           <a:ln/>
         </p:spPr>
+        <p:txBody>
+          <a:bodyPr/>
+          <a:p/>
+        </p:txBody>
       </p:sp>
       <p:sp xmlns:p="http://schemas.openxmlformats.org/presentationml/2006/main" xmlns:a="http://schemas.openxmlformats.org/drawingml/2006/main" xmlns:r="http://schemas.openxmlformats.org/officeDocument/2006/relationships">
         <p:nvSpPr>
@@ -15727,6 +15794,10 @@
             <a:prstDash val="solid"/>
           </a:ln>
         </p:spPr>
+        <p:txBody>
+          <a:bodyPr/>
+          <a:p/>
+        </p:txBody>
       </p:sp>
       <p:sp xmlns:p="http://schemas.openxmlformats.org/presentationml/2006/main" xmlns:a="http://schemas.openxmlformats.org/drawingml/2006/main" xmlns:r="http://schemas.openxmlformats.org/officeDocument/2006/relationships">
         <p:nvSpPr>
@@ -15788,6 +15859,10 @@
           </a:solidFill>
           <a:ln/>
         </p:spPr>
+        <p:txBody>
+          <a:bodyPr/>
+          <a:p/>
+        </p:txBody>
       </p:sp>
       <p:sp xmlns:p="http://schemas.openxmlformats.org/presentationml/2006/main" xmlns:a="http://schemas.openxmlformats.org/drawingml/2006/main" xmlns:r="http://schemas.openxmlformats.org/officeDocument/2006/relationships">
         <p:nvSpPr>
@@ -15810,6 +15885,10 @@
             <a:prstDash val="solid"/>
           </a:ln>
         </p:spPr>
+        <p:txBody>
+          <a:bodyPr/>
+          <a:p/>
+        </p:txBody>
       </p:sp>
       <p:sp xmlns:p="http://schemas.openxmlformats.org/presentationml/2006/main" xmlns:a="http://schemas.openxmlformats.org/drawingml/2006/main" xmlns:r="http://schemas.openxmlformats.org/officeDocument/2006/relationships">
         <p:nvSpPr>
@@ -15871,6 +15950,10 @@
           </a:solidFill>
           <a:ln/>
         </p:spPr>
+        <p:txBody>
+          <a:bodyPr/>
+          <a:p/>
+        </p:txBody>
       </p:sp>
       <p:sp xmlns:p="http://schemas.openxmlformats.org/presentationml/2006/main" xmlns:a="http://schemas.openxmlformats.org/drawingml/2006/main" xmlns:r="http://schemas.openxmlformats.org/officeDocument/2006/relationships">
         <p:nvSpPr>
@@ -19734,6 +19817,10 @@
           </a:solidFill>
           <a:ln/>
         </p:spPr>
+        <p:txBody>
+          <a:bodyPr/>
+          <a:p/>
+        </p:txBody>
       </p:sp>
       <p:sp xmlns:p="http://schemas.openxmlformats.org/presentationml/2006/main" xmlns:a="http://schemas.openxmlformats.org/drawingml/2006/main" xmlns:r="http://schemas.openxmlformats.org/officeDocument/2006/relationships">
         <p:nvSpPr>
@@ -19754,6 +19841,10 @@
           </a:solidFill>
           <a:ln/>
         </p:spPr>
+        <p:txBody>
+          <a:bodyPr/>
+          <a:p/>
+        </p:txBody>
       </p:sp>
       <p:sp xmlns:p="http://schemas.openxmlformats.org/presentationml/2006/main" xmlns:a="http://schemas.openxmlformats.org/drawingml/2006/main" xmlns:r="http://schemas.openxmlformats.org/officeDocument/2006/relationships">
         <p:nvSpPr>
@@ -19818,6 +19909,10 @@
           </a:solidFill>
           <a:ln/>
         </p:spPr>
+        <p:txBody>
+          <a:bodyPr/>
+          <a:p/>
+        </p:txBody>
       </p:sp>
       <p:sp xmlns:p="http://schemas.openxmlformats.org/presentationml/2006/main" xmlns:a="http://schemas.openxmlformats.org/drawingml/2006/main" xmlns:r="http://schemas.openxmlformats.org/officeDocument/2006/relationships">
         <p:nvSpPr>
@@ -19882,6 +19977,10 @@
           </a:solidFill>
           <a:ln/>
         </p:spPr>
+        <p:txBody>
+          <a:bodyPr/>
+          <a:p/>
+        </p:txBody>
       </p:sp>
       <p:sp xmlns:p="http://schemas.openxmlformats.org/presentationml/2006/main" xmlns:a="http://schemas.openxmlformats.org/drawingml/2006/main" xmlns:r="http://schemas.openxmlformats.org/officeDocument/2006/relationships">
         <p:nvSpPr>
@@ -19946,6 +20045,10 @@
           </a:solidFill>
           <a:ln/>
         </p:spPr>
+        <p:txBody>
+          <a:bodyPr/>
+          <a:p/>
+        </p:txBody>
       </p:sp>
       <p:sp xmlns:p="http://schemas.openxmlformats.org/presentationml/2006/main" xmlns:a="http://schemas.openxmlformats.org/drawingml/2006/main" xmlns:r="http://schemas.openxmlformats.org/officeDocument/2006/relationships">
         <p:nvSpPr>
@@ -20010,6 +20113,10 @@
           </a:solidFill>
           <a:ln/>
         </p:spPr>
+        <p:txBody>
+          <a:bodyPr/>
+          <a:p/>
+        </p:txBody>
       </p:sp>
       <p:sp xmlns:p="http://schemas.openxmlformats.org/presentationml/2006/main" xmlns:a="http://schemas.openxmlformats.org/drawingml/2006/main" xmlns:r="http://schemas.openxmlformats.org/officeDocument/2006/relationships">
         <p:nvSpPr>
@@ -20074,6 +20181,10 @@
           </a:solidFill>
           <a:ln/>
         </p:spPr>
+        <p:txBody>
+          <a:bodyPr/>
+          <a:p/>
+        </p:txBody>
       </p:sp>
       <p:sp xmlns:p="http://schemas.openxmlformats.org/presentationml/2006/main" xmlns:a="http://schemas.openxmlformats.org/drawingml/2006/main" xmlns:r="http://schemas.openxmlformats.org/officeDocument/2006/relationships">
         <p:nvSpPr>
@@ -20138,6 +20249,10 @@
           </a:solidFill>
           <a:ln/>
         </p:spPr>
+        <p:txBody>
+          <a:bodyPr/>
+          <a:p/>
+        </p:txBody>
       </p:sp>
       <p:sp xmlns:p="http://schemas.openxmlformats.org/presentationml/2006/main" xmlns:a="http://schemas.openxmlformats.org/drawingml/2006/main" xmlns:r="http://schemas.openxmlformats.org/officeDocument/2006/relationships">
         <p:nvSpPr>
@@ -20202,6 +20317,10 @@
           </a:solidFill>
           <a:ln/>
         </p:spPr>
+        <p:txBody>
+          <a:bodyPr/>
+          <a:p/>
+        </p:txBody>
       </p:sp>
       <p:sp xmlns:p="http://schemas.openxmlformats.org/presentationml/2006/main" xmlns:a="http://schemas.openxmlformats.org/drawingml/2006/main" xmlns:r="http://schemas.openxmlformats.org/officeDocument/2006/relationships">
         <p:nvSpPr>
@@ -20266,6 +20385,10 @@
           </a:solidFill>
           <a:ln/>
         </p:spPr>
+        <p:txBody>
+          <a:bodyPr/>
+          <a:p/>
+        </p:txBody>
       </p:sp>
       <p:sp xmlns:p="http://schemas.openxmlformats.org/presentationml/2006/main" xmlns:a="http://schemas.openxmlformats.org/drawingml/2006/main" xmlns:r="http://schemas.openxmlformats.org/officeDocument/2006/relationships">
         <p:nvSpPr>
@@ -20330,6 +20453,10 @@
           </a:solidFill>
           <a:ln/>
         </p:spPr>
+        <p:txBody>
+          <a:bodyPr/>
+          <a:p/>
+        </p:txBody>
       </p:sp>
       <p:sp xmlns:p="http://schemas.openxmlformats.org/presentationml/2006/main" xmlns:a="http://schemas.openxmlformats.org/drawingml/2006/main" xmlns:r="http://schemas.openxmlformats.org/officeDocument/2006/relationships">
         <p:nvSpPr>
@@ -20369,7 +20496,7 @@
                 <a:ea typeface="+mn-ea"/>
                 <a:cs typeface="+mn-cs"/>
               </a:rPr>
-              <a:t>Provided by the instructor: the </a:t>
+              <a:t>From the course lead: a link to the </a:t>
             </a:r>
             <a:r>
               <a:rPr lang="en-US" sz="1800" dirty="0">
@@ -20380,7 +20507,7 @@
                 <a:ea typeface="Consolas" pitchFamily="34" charset="-122"/>
                 <a:cs typeface="Consolas" pitchFamily="34" charset="-120"/>
               </a:rPr>
-              <a:t>beam-calc </a:t>
+              <a:t>beam-calc</a:t>
             </a:r>
             <a:r>
               <a:rPr lang="en-US" sz="1950" dirty="0">
@@ -20391,7 +20518,7 @@
                 <a:ea typeface="+mn-ea"/>
                 <a:cs typeface="+mn-cs"/>
               </a:rPr>
-              <a:t>template repository.</a:t>
+              <a:t> template repo.</a:t>
             </a:r>
             <a:endParaRPr lang="en-US" sz="1950" dirty="0"/>
           </a:p>

</xml_diff>